<commit_message>
Update for any changes
</commit_message>
<xml_diff>
--- a/PHASE ONE PROJECT PRESENTATION.pptx
+++ b/PHASE ONE PROJECT PRESENTATION.pptx
@@ -3381,7 +3381,9 @@
         </p:nvSpPr>
         <p:spPr/>
         <p:txBody>
-          <a:bodyPr/>
+          <a:bodyPr>
+            <a:normAutofit/>
+          </a:bodyPr>
           <a:lstStyle/>
           <a:p>
             <a:r>
@@ -3390,9 +3392,55 @@
                   <a:schemeClr val="tx1"/>
                 </a:solidFill>
               </a:rPr>
-              <a:t>PHASE ONE PROJECT</a:t>
-            </a:r>
-            <a:endParaRPr lang="en-GB" b="1" dirty="0">
+              <a:t>PHASE ONE </a:t>
+            </a:r>
+            <a:r>
+              <a:rPr lang="en-GB" b="1" dirty="0" smtClean="0">
+                <a:solidFill>
+                  <a:schemeClr val="tx1"/>
+                </a:solidFill>
+              </a:rPr>
+              <a:t>PROJECT</a:t>
+            </a:r>
+            <a:br>
+              <a:rPr lang="en-GB" b="1" dirty="0" smtClean="0">
+                <a:solidFill>
+                  <a:schemeClr val="tx1"/>
+                </a:solidFill>
+              </a:rPr>
+            </a:br>
+            <a:r>
+              <a:rPr lang="en-GB" sz="3300" b="1" dirty="0">
+                <a:solidFill>
+                  <a:schemeClr val="tx1"/>
+                </a:solidFill>
+              </a:rPr>
+              <a:t/>
+            </a:r>
+            <a:br>
+              <a:rPr lang="en-GB" sz="3300" b="1" dirty="0">
+                <a:solidFill>
+                  <a:schemeClr val="tx1"/>
+                </a:solidFill>
+              </a:rPr>
+            </a:br>
+            <a:r>
+              <a:rPr lang="en-GB" sz="3300" b="1" dirty="0" err="1" smtClean="0">
+                <a:solidFill>
+                  <a:schemeClr val="tx1"/>
+                </a:solidFill>
+              </a:rPr>
+              <a:t>Moringa</a:t>
+            </a:r>
+            <a:r>
+              <a:rPr lang="en-GB" sz="3300" b="1" dirty="0" smtClean="0">
+                <a:solidFill>
+                  <a:schemeClr val="tx1"/>
+                </a:solidFill>
+              </a:rPr>
+              <a:t> School-Data Science</a:t>
+            </a:r>
+            <a:endParaRPr lang="en-GB" sz="3300" b="1" dirty="0">
               <a:solidFill>
                 <a:schemeClr val="tx1"/>
               </a:solidFill>
@@ -3410,7 +3458,12 @@
             <p:ph type="subTitle" idx="1"/>
           </p:nvPr>
         </p:nvSpPr>
-        <p:spPr/>
+        <p:spPr>
+          <a:xfrm>
+            <a:off x="1172204" y="4991088"/>
+            <a:ext cx="7315200" cy="914400"/>
+          </a:xfrm>
+        </p:spPr>
         <p:txBody>
           <a:bodyPr/>
           <a:lstStyle/>
@@ -4234,7 +4287,7 @@
             </a:pPr>
             <a:r>
               <a:rPr lang="en-GB" dirty="0" smtClean="0"/>
-              <a:t>Number of accidents bas influenced by weather</a:t>
+              <a:t>Number of accidents as influenced by weather</a:t>
             </a:r>
           </a:p>
           <a:p>
@@ -4351,25 +4404,13 @@
           <a:p>
             <a:r>
               <a:rPr lang="en-GB" dirty="0" smtClean="0"/>
-              <a:t>The data should have included fatalities caused by pilots; maybe categorized </a:t>
-            </a:r>
-            <a:r>
-              <a:rPr lang="en-GB" dirty="0" err="1" smtClean="0"/>
-              <a:t>interms</a:t>
-            </a:r>
+              <a:t>The data should have included fatalities caused by pilots; maybe categorized in terms of pilot skill level, level of rest before the flight and number of trips in the same route. This would make the accident analysis more comprehensive</a:t>
+            </a:r>
+          </a:p>
+          <a:p>
             <a:r>
               <a:rPr lang="en-GB" dirty="0" smtClean="0"/>
-              <a:t> of pilot skill level, level of rest before the flight and number of trips in the same route. This would make the accident analysis more comprehensive</a:t>
-            </a:r>
-          </a:p>
-          <a:p>
-            <a:r>
-              <a:rPr lang="en-GB" dirty="0" smtClean="0"/>
-              <a:t>It was not possible to tell the most common cause of accident using </a:t>
-            </a:r>
-            <a:r>
-              <a:rPr lang="en-GB" smtClean="0"/>
-              <a:t>this dataset</a:t>
+              <a:t>It was not possible to tell the most common cause of accident using this dataset</a:t>
             </a:r>
             <a:endParaRPr lang="en-GB" dirty="0"/>
           </a:p>

</xml_diff>